<commit_message>
Stage 1 rerun, label-variance ceiling in audit, notes and slides for Oct 7 meeting
</commit_message>
<xml_diff>
--- a/docs/notes/Mina_Meeting_Slides_2026-10-07.pptx
+++ b/docs/notes/Mina_Meeting_Slides_2026-10-07.pptx
@@ -2547,6 +2547,10 @@
             <a:prstDash val="solid"/>
           </a:ln>
         </p:spPr>
+        <p:txBody>
+          <a:bodyPr/>
+          <a:p/>
+        </p:txBody>
       </p:sp>
       <p:sp>
         <p:nvSpPr>
@@ -2613,6 +2617,10 @@
             <a:prstDash val="solid"/>
           </a:ln>
         </p:spPr>
+        <p:txBody>
+          <a:bodyPr/>
+          <a:p/>
+        </p:txBody>
       </p:sp>
       <p:sp>
         <p:nvSpPr>
@@ -2679,6 +2687,10 @@
             <a:prstDash val="solid"/>
           </a:ln>
         </p:spPr>
+        <p:txBody>
+          <a:bodyPr/>
+          <a:p/>
+        </p:txBody>
       </p:sp>
       <p:sp>
         <p:nvSpPr>
@@ -6885,6 +6897,10 @@
             <a:prstDash val="solid"/>
           </a:ln>
         </p:spPr>
+        <p:txBody>
+          <a:bodyPr/>
+          <a:p/>
+        </p:txBody>
       </p:sp>
       <p:sp>
         <p:nvSpPr>
@@ -6990,6 +7006,10 @@
             <a:prstDash val="solid"/>
           </a:ln>
         </p:spPr>
+        <p:txBody>
+          <a:bodyPr/>
+          <a:p/>
+        </p:txBody>
       </p:sp>
       <p:sp>
         <p:nvSpPr>
@@ -9624,6 +9644,10 @@
             <a:prstDash val="solid"/>
           </a:ln>
         </p:spPr>
+        <p:txBody>
+          <a:bodyPr/>
+          <a:p/>
+        </p:txBody>
       </p:sp>
       <p:sp>
         <p:nvSpPr>
@@ -9729,6 +9753,10 @@
             <a:prstDash val="solid"/>
           </a:ln>
         </p:spPr>
+        <p:txBody>
+          <a:bodyPr/>
+          <a:p/>
+        </p:txBody>
       </p:sp>
       <p:sp>
         <p:nvSpPr>
@@ -10007,6 +10035,10 @@
             <a:prstDash val="solid"/>
           </a:ln>
         </p:spPr>
+        <p:txBody>
+          <a:bodyPr/>
+          <a:p/>
+        </p:txBody>
       </p:sp>
       <p:sp>
         <p:nvSpPr>
@@ -10112,6 +10144,10 @@
             <a:prstDash val="solid"/>
           </a:ln>
         </p:spPr>
+        <p:txBody>
+          <a:bodyPr/>
+          <a:p/>
+        </p:txBody>
       </p:sp>
       <p:sp>
         <p:nvSpPr>
@@ -10217,6 +10253,10 @@
             <a:prstDash val="solid"/>
           </a:ln>
         </p:spPr>
+        <p:txBody>
+          <a:bodyPr/>
+          <a:p/>
+        </p:txBody>
       </p:sp>
       <p:sp>
         <p:nvSpPr>
@@ -10361,6 +10401,591 @@
                 <a:ea typeface="Calibri" pitchFamily="34" charset="-122"/>
                 <a:cs typeface="Calibri" pitchFamily="34" charset="-120"/>
               </a:rPr>
+              <a:t>STAGE 2 · WHAT ALIGNMENT MEANS</a:t>
+            </a:r>
+            <a:endParaRPr lang="en-US" sz="1300" dirty="0"/>
+          </a:p>
+        </p:txBody>
+      </p:sp>
+      <p:sp>
+        <p:nvSpPr>
+          <p:cNvPr id="3" name="Title"/>
+          <p:cNvSpPr txBox="1"/>
+          <p:nvPr/>
+        </p:nvSpPr>
+        <p:spPr>
+          <a:xfrm>
+            <a:off x="685800" y="777240"/>
+            <a:ext cx="10817352" cy="685800"/>
+          </a:xfrm>
+          <a:prstGeom prst="rect">
+            <a:avLst/>
+          </a:prstGeom>
+          <a:noFill/>
+          <a:ln/>
+        </p:spPr>
+        <p:txBody>
+          <a:bodyPr wrap="square" lIns="0" tIns="0" rIns="0" bIns="0" rtlCol="0" anchor="ctr"/>
+          <a:lstStyle/>
+          <a:p>
+            <a:pPr indent="0" marL="0">
+              <a:buNone/>
+            </a:pPr>
+            <a:r>
+              <a:rPr lang="en-US" sz="3200" b="1" dirty="0">
+                <a:solidFill>
+                  <a:srgbClr val="1E2A20"/>
+                </a:solidFill>
+                <a:latin typeface="Cambria" pitchFamily="34" charset="0"/>
+                <a:ea typeface="Cambria" pitchFamily="34" charset="-122"/>
+                <a:cs typeface="Cambria" pitchFamily="34" charset="-120"/>
+              </a:rPr>
+              <a:t>Two kinds of alignment: one given, one measured</a:t>
+            </a:r>
+            <a:endParaRPr lang="en-US" sz="3200" dirty="0"/>
+          </a:p>
+        </p:txBody>
+      </p:sp>
+      <p:sp>
+        <p:nvSpPr>
+          <p:cNvPr id="4" name="Card 1"/>
+          <p:cNvSpPr/>
+          <p:nvPr/>
+        </p:nvSpPr>
+        <p:spPr>
+          <a:xfrm>
+            <a:off x="685800" y="1645920"/>
+            <a:ext cx="5271516" cy="3566160"/>
+          </a:xfrm>
+          <a:prstGeom prst="roundRect">
+            <a:avLst>
+              <a:gd name="adj" fmla="val 3902"/>
+            </a:avLst>
+          </a:prstGeom>
+          <a:solidFill>
+            <a:srgbClr val="EEF3EA"/>
+          </a:solidFill>
+          <a:ln w="12700">
+            <a:solidFill>
+              <a:srgbClr val="EEF3EA"/>
+            </a:solidFill>
+            <a:prstDash val="solid"/>
+          </a:ln>
+        </p:spPr>
+        <p:txBody>
+          <a:bodyPr/>
+          <a:p/>
+        </p:txBody>
+      </p:sp>
+      <p:sp>
+        <p:nvSpPr>
+          <p:cNvPr id="5" name="Card 1 title"/>
+          <p:cNvSpPr txBox="1"/>
+          <p:nvPr/>
+        </p:nvSpPr>
+        <p:spPr>
+          <a:xfrm>
+            <a:off x="960120" y="1810512"/>
+            <a:ext cx="4722876" cy="365760"/>
+          </a:xfrm>
+          <a:prstGeom prst="rect">
+            <a:avLst/>
+          </a:prstGeom>
+          <a:noFill/>
+          <a:ln/>
+        </p:spPr>
+        <p:txBody>
+          <a:bodyPr wrap="square" lIns="0" tIns="0" rIns="0" bIns="0" rtlCol="0" anchor="ctr"/>
+          <a:lstStyle/>
+          <a:p>
+            <a:pPr indent="0" marL="0">
+              <a:buNone/>
+            </a:pPr>
+            <a:r>
+              <a:rPr lang="en-US" sz="1600" b="1" dirty="0">
+                <a:solidFill>
+                  <a:srgbClr val="1E2A20"/>
+                </a:solidFill>
+                <a:latin typeface="Calibri" pitchFamily="34" charset="0"/>
+                <a:ea typeface="Calibri" pitchFamily="34" charset="-122"/>
+                <a:cs typeface="Calibri" pitchFamily="34" charset="-120"/>
+              </a:rPr>
+              <a:t>Positional alignment: given by biology</a:t>
+            </a:r>
+            <a:endParaRPr lang="en-US" sz="1600" dirty="0"/>
+          </a:p>
+        </p:txBody>
+      </p:sp>
+      <p:sp>
+        <p:nvSpPr>
+          <p:cNvPr id="6" name="Card 1 body"/>
+          <p:cNvSpPr txBox="1"/>
+          <p:nvPr/>
+        </p:nvSpPr>
+        <p:spPr>
+          <a:xfrm>
+            <a:off x="960120" y="2249424"/>
+            <a:ext cx="4722876" cy="2798064"/>
+          </a:xfrm>
+          <a:prstGeom prst="rect">
+            <a:avLst/>
+          </a:prstGeom>
+          <a:noFill/>
+          <a:ln/>
+        </p:spPr>
+        <p:txBody>
+          <a:bodyPr wrap="square" lIns="0" tIns="0" rIns="0" bIns="0" rtlCol="0" anchor="t"/>
+          <a:lstStyle/>
+          <a:p>
+            <a:pPr indent="0" marL="0">
+              <a:spcAft>
+                <a:spcPts val="700"/>
+              </a:spcAft>
+              <a:buNone/>
+            </a:pPr>
+            <a:r>
+              <a:rPr lang="en-US" sz="1400" dirty="0">
+                <a:solidFill>
+                  <a:srgbClr val="46524A"/>
+                </a:solidFill>
+                <a:latin typeface="Calibri" pitchFamily="34" charset="0"/>
+                <a:ea typeface="Calibri" pitchFamily="34" charset="-122"/>
+                <a:cs typeface="Calibri" pitchFamily="34" charset="-120"/>
+              </a:rPr>
+              <a:t>Step t in every input must mean the same place in the gene, like video frame t and audio window t. Coupled Mamba needs this.</a:t>
+            </a:r>
+            <a:endParaRPr lang="en-US" sz="1400" dirty="0"/>
+          </a:p>
+          <a:p>
+            <a:pPr indent="0" marL="0">
+              <a:spcAft>
+                <a:spcPts val="300"/>
+              </a:spcAft>
+              <a:buNone/>
+            </a:pPr>
+            <a:r>
+              <a:rPr lang="en-US" sz="1400" b="1" dirty="0">
+                <a:solidFill>
+                  <a:srgbClr val="1E2A20"/>
+                </a:solidFill>
+                <a:latin typeface="Calibri" pitchFamily="34" charset="0"/>
+                <a:ea typeface="Calibri" pitchFamily="34" charset="-122"/>
+                <a:cs typeface="Calibri" pitchFamily="34" charset="-120"/>
+              </a:rPr>
+              <a:t>Stability: </a:t>
+            </a:r>
+            <a:r>
+              <a:rPr lang="en-US" sz="1400" dirty="0">
+                <a:solidFill>
+                  <a:srgbClr val="46524A"/>
+                </a:solidFill>
+                <a:latin typeface="Calibri" pitchFamily="34" charset="0"/>
+                <a:ea typeface="Calibri" pitchFamily="34" charset="-122"/>
+                <a:cs typeface="Calibri" pitchFamily="34" charset="-120"/>
+              </a:rPr>
+              <a:t>each codon maps to one amino acid, so every stream can be resampled to one codon grid. For a 900-nt coding sequence:</a:t>
+            </a:r>
+            <a:endParaRPr lang="en-US" sz="1400" dirty="0"/>
+          </a:p>
+          <a:p>
+            <a:pPr marL="285750" indent="-285750">
+              <a:spcAft>
+                <a:spcPts val="200"/>
+              </a:spcAft>
+              <a:buSzPct val="100000"/>
+              <a:buChar char="•"/>
+            </a:pPr>
+            <a:r>
+              <a:rPr lang="en-US" sz="1400" dirty="0">
+                <a:solidFill>
+                  <a:srgbClr val="46524A"/>
+                </a:solidFill>
+                <a:latin typeface="Calibri" pitchFamily="34" charset="0"/>
+                <a:ea typeface="Calibri" pitchFamily="34" charset="-122"/>
+                <a:cs typeface="Calibri" pitchFamily="34" charset="-120"/>
+              </a:rPr>
+              <a:t>RNA-FM: 900 nucleotide tokens, averaged in threes</a:t>
+            </a:r>
+            <a:endParaRPr lang="en-US" sz="1400" dirty="0"/>
+          </a:p>
+          <a:p>
+            <a:pPr marL="285750" indent="-285750">
+              <a:spcAft>
+                <a:spcPts val="200"/>
+              </a:spcAft>
+              <a:buSzPct val="100000"/>
+              <a:buChar char="•"/>
+            </a:pPr>
+            <a:r>
+              <a:rPr lang="en-US" sz="1400" dirty="0">
+                <a:solidFill>
+                  <a:srgbClr val="46524A"/>
+                </a:solidFill>
+                <a:latin typeface="Calibri" pitchFamily="34" charset="0"/>
+                <a:ea typeface="Calibri" pitchFamily="34" charset="-122"/>
+                <a:cs typeface="Calibri" pitchFamily="34" charset="-120"/>
+              </a:rPr>
+              <a:t>NT 500M: 150 six-nucleotide tokens, each split in two</a:t>
+            </a:r>
+            <a:endParaRPr lang="en-US" sz="1400" dirty="0"/>
+          </a:p>
+          <a:p>
+            <a:pPr marL="285750" indent="-285750">
+              <a:spcAft>
+                <a:spcPts val="700"/>
+              </a:spcAft>
+              <a:buSzPct val="100000"/>
+              <a:buChar char="•"/>
+            </a:pPr>
+            <a:r>
+              <a:rPr lang="en-US" sz="1400" dirty="0">
+                <a:solidFill>
+                  <a:srgbClr val="46524A"/>
+                </a:solidFill>
+                <a:latin typeface="Calibri" pitchFamily="34" charset="0"/>
+                <a:ea typeface="Calibri" pitchFamily="34" charset="-122"/>
+                <a:cs typeface="Calibri" pitchFamily="34" charset="-120"/>
+              </a:rPr>
+              <a:t>CaLM (300 codons), ESM-2 (about 300 amino acids): already one per codon</a:t>
+            </a:r>
+            <a:endParaRPr lang="en-US" sz="1400" dirty="0"/>
+          </a:p>
+          <a:p>
+            <a:pPr indent="0" marL="0">
+              <a:buNone/>
+            </a:pPr>
+            <a:r>
+              <a:rPr lang="en-US" sz="1400" b="1" dirty="0">
+                <a:solidFill>
+                  <a:srgbClr val="1E2A20"/>
+                </a:solidFill>
+                <a:latin typeface="Calibri" pitchFamily="34" charset="0"/>
+                <a:ea typeface="Calibri" pitchFamily="34" charset="-122"/>
+                <a:cs typeface="Calibri" pitchFamily="34" charset="-120"/>
+              </a:rPr>
+              <a:t>GTEx: </a:t>
+            </a:r>
+            <a:r>
+              <a:rPr lang="en-US" sz="1400" dirty="0">
+                <a:solidFill>
+                  <a:srgbClr val="46524A"/>
+                </a:solidFill>
+                <a:latin typeface="Calibri" pitchFamily="34" charset="0"/>
+                <a:ea typeface="Calibri" pitchFamily="34" charset="-122"/>
+                <a:cs typeface="Calibri" pitchFamily="34" charset="-120"/>
+              </a:rPr>
+              <a:t>promoter DNA, transcript, and protein have no position-by-position match, so fusion uses cross-attention.</a:t>
+            </a:r>
+            <a:endParaRPr lang="en-US" sz="1400" dirty="0"/>
+          </a:p>
+        </p:txBody>
+      </p:sp>
+      <p:sp>
+        <p:nvSpPr>
+          <p:cNvPr id="7" name="Card 2"/>
+          <p:cNvSpPr/>
+          <p:nvPr/>
+        </p:nvSpPr>
+        <p:spPr>
+          <a:xfrm>
+            <a:off x="6231636" y="1645920"/>
+            <a:ext cx="5271516" cy="3566160"/>
+          </a:xfrm>
+          <a:prstGeom prst="roundRect">
+            <a:avLst>
+              <a:gd name="adj" fmla="val 3902"/>
+            </a:avLst>
+          </a:prstGeom>
+          <a:solidFill>
+            <a:srgbClr val="EEF3EA"/>
+          </a:solidFill>
+          <a:ln w="12700">
+            <a:solidFill>
+              <a:srgbClr val="EEF3EA"/>
+            </a:solidFill>
+            <a:prstDash val="solid"/>
+          </a:ln>
+        </p:spPr>
+        <p:txBody>
+          <a:bodyPr/>
+          <a:p/>
+        </p:txBody>
+      </p:sp>
+      <p:sp>
+        <p:nvSpPr>
+          <p:cNvPr id="8" name="Card 2 title"/>
+          <p:cNvSpPr txBox="1"/>
+          <p:nvPr/>
+        </p:nvSpPr>
+        <p:spPr>
+          <a:xfrm>
+            <a:off x="6505956" y="1810512"/>
+            <a:ext cx="4722876" cy="365760"/>
+          </a:xfrm>
+          <a:prstGeom prst="rect">
+            <a:avLst/>
+          </a:prstGeom>
+          <a:noFill/>
+          <a:ln/>
+        </p:spPr>
+        <p:txBody>
+          <a:bodyPr wrap="square" lIns="0" tIns="0" rIns="0" bIns="0" rtlCol="0" anchor="ctr"/>
+          <a:lstStyle/>
+          <a:p>
+            <a:pPr indent="0" marL="0">
+              <a:buNone/>
+            </a:pPr>
+            <a:r>
+              <a:rPr lang="en-US" sz="1600" b="1" dirty="0">
+                <a:solidFill>
+                  <a:srgbClr val="1E2A20"/>
+                </a:solidFill>
+                <a:latin typeface="Calibri" pitchFamily="34" charset="0"/>
+                <a:ea typeface="Calibri" pitchFamily="34" charset="-122"/>
+                <a:cs typeface="Calibri" pitchFamily="34" charset="-120"/>
+              </a:rPr>
+              <a:t>Representational alignment: measured</a:t>
+            </a:r>
+            <a:endParaRPr lang="en-US" sz="1600" dirty="0"/>
+          </a:p>
+        </p:txBody>
+      </p:sp>
+      <p:sp>
+        <p:nvSpPr>
+          <p:cNvPr id="9" name="Card 2 body"/>
+          <p:cNvSpPr txBox="1"/>
+          <p:nvPr/>
+        </p:nvSpPr>
+        <p:spPr>
+          <a:xfrm>
+            <a:off x="6505956" y="2249424"/>
+            <a:ext cx="4722876" cy="2798064"/>
+          </a:xfrm>
+          <a:prstGeom prst="rect">
+            <a:avLst/>
+          </a:prstGeom>
+          <a:noFill/>
+          <a:ln/>
+        </p:spPr>
+        <p:txBody>
+          <a:bodyPr wrap="square" lIns="0" tIns="0" rIns="0" bIns="0" rtlCol="0" anchor="t"/>
+          <a:lstStyle/>
+          <a:p>
+            <a:pPr indent="0" marL="0">
+              <a:spcAft>
+                <a:spcPts val="700"/>
+              </a:spcAft>
+              <a:buNone/>
+            </a:pPr>
+            <a:r>
+              <a:rPr lang="en-US" sz="1400" dirty="0">
+                <a:solidFill>
+                  <a:srgbClr val="46524A"/>
+                </a:solidFill>
+                <a:latin typeface="Calibri" pitchFamily="34" charset="0"/>
+                <a:ea typeface="Calibri" pitchFamily="34" charset="-122"/>
+                <a:cs typeface="Calibri" pitchFamily="34" charset="-120"/>
+              </a:rPr>
+              <a:t>Do two encoders see the same genes as similar? Stage 1 measured it with CKA, nearest neighbors, RSA, and CCA retrieval.</a:t>
+            </a:r>
+            <a:endParaRPr lang="en-US" sz="1400" dirty="0"/>
+          </a:p>
+          <a:p>
+            <a:pPr indent="0" marL="0">
+              <a:spcAft>
+                <a:spcPts val="700"/>
+              </a:spcAft>
+              <a:buNone/>
+            </a:pPr>
+            <a:r>
+              <a:rPr lang="en-US" sz="1400" b="1" dirty="0">
+                <a:solidFill>
+                  <a:srgbClr val="1E2A20"/>
+                </a:solidFill>
+                <a:latin typeface="Calibri" pitchFamily="34" charset="0"/>
+                <a:ea typeface="Calibri" pitchFamily="34" charset="-122"/>
+                <a:cs typeface="Calibri" pitchFamily="34" charset="-120"/>
+              </a:rPr>
+              <a:t>Mostly composition. </a:t>
+            </a:r>
+            <a:r>
+              <a:rPr lang="en-US" sz="1400" dirty="0">
+                <a:solidFill>
+                  <a:srgbClr val="46524A"/>
+                </a:solidFill>
+                <a:latin typeface="Calibri" pitchFamily="34" charset="0"/>
+                <a:ea typeface="Calibri" pitchFamily="34" charset="-122"/>
+                <a:cs typeface="Calibri" pitchFamily="34" charset="-120"/>
+              </a:rPr>
+              <a:t>Removing letter, codon, and amino-acid counts cuts CKA 52% to 90% for every pair with a DNA encoder.</a:t>
+            </a:r>
+            <a:endParaRPr lang="en-US" sz="1400" dirty="0"/>
+          </a:p>
+          <a:p>
+            <a:pPr indent="0" marL="0">
+              <a:spcAft>
+                <a:spcPts val="700"/>
+              </a:spcAft>
+              <a:buNone/>
+            </a:pPr>
+            <a:r>
+              <a:rPr lang="en-US" sz="1400" b="1" dirty="0">
+                <a:solidFill>
+                  <a:srgbClr val="1E2A20"/>
+                </a:solidFill>
+                <a:latin typeface="Calibri" pitchFamily="34" charset="0"/>
+                <a:ea typeface="Calibri" pitchFamily="34" charset="-122"/>
+                <a:cs typeface="Calibri" pitchFamily="34" charset="-120"/>
+              </a:rPr>
+              <a:t>Few pairs survive. </a:t>
+            </a:r>
+            <a:r>
+              <a:rPr lang="en-US" sz="1400" dirty="0">
+                <a:solidFill>
+                  <a:srgbClr val="46524A"/>
+                </a:solidFill>
+                <a:latin typeface="Calibri" pitchFamily="34" charset="0"/>
+                <a:ea typeface="Calibri" pitchFamily="34" charset="-122"/>
+                <a:cs typeface="Calibri" pitchFamily="34" charset="-120"/>
+              </a:rPr>
+              <a:t>ESM-2 models, RNA-FM with RiNALMo, and CaLM with protein, which still finds its protein partner 58% to 69% of the time (chance 0.3%).</a:t>
+            </a:r>
+            <a:endParaRPr lang="en-US" sz="1400" dirty="0"/>
+          </a:p>
+          <a:p>
+            <a:pPr indent="0" marL="0">
+              <a:buNone/>
+            </a:pPr>
+            <a:r>
+              <a:rPr lang="en-US" sz="1400" b="1" dirty="0">
+                <a:solidFill>
+                  <a:srgbClr val="1E2A20"/>
+                </a:solidFill>
+                <a:latin typeface="Calibri" pitchFamily="34" charset="0"/>
+                <a:ea typeface="Calibri" pitchFamily="34" charset="-122"/>
+                <a:cs typeface="Calibri" pitchFamily="34" charset="-120"/>
+              </a:rPr>
+              <a:t>Not usefulness. </a:t>
+            </a:r>
+            <a:r>
+              <a:rPr lang="en-US" sz="1400" dirty="0">
+                <a:solidFill>
+                  <a:srgbClr val="46524A"/>
+                </a:solidFill>
+                <a:latin typeface="Calibri" pitchFamily="34" charset="0"/>
+                <a:ea typeface="Calibri" pitchFamily="34" charset="-122"/>
+                <a:cs typeface="Calibri" pitchFamily="34" charset="-120"/>
+              </a:rPr>
+              <a:t>Alignment never tracks prediction error (66 pairs, both datasets), and some of the best pairings barely align.</a:t>
+            </a:r>
+            <a:endParaRPr lang="en-US" sz="1400" dirty="0"/>
+          </a:p>
+        </p:txBody>
+      </p:sp>
+      <p:sp>
+        <p:nvSpPr>
+          <p:cNvPr id="10" name="Definition"/>
+          <p:cNvSpPr txBox="1"/>
+          <p:nvPr/>
+        </p:nvSpPr>
+        <p:spPr>
+          <a:xfrm>
+            <a:off x="685800" y="5394960"/>
+            <a:ext cx="10817352" cy="457200"/>
+          </a:xfrm>
+          <a:prstGeom prst="rect">
+            <a:avLst/>
+          </a:prstGeom>
+          <a:noFill/>
+          <a:ln/>
+        </p:spPr>
+        <p:txBody>
+          <a:bodyPr wrap="square" lIns="0" tIns="0" rIns="0" bIns="0" rtlCol="0" anchor="ctr"/>
+          <a:lstStyle/>
+          <a:p>
+            <a:pPr indent="0" marL="0">
+              <a:buNone/>
+            </a:pPr>
+            <a:r>
+              <a:rPr lang="en-US" sz="1300" i="1" dirty="0">
+                <a:solidFill>
+                  <a:srgbClr val="46524A"/>
+                </a:solidFill>
+                <a:latin typeface="Calibri" pitchFamily="34" charset="0"/>
+                <a:ea typeface="Calibri" pitchFamily="34" charset="-122"/>
+                <a:cs typeface="Calibri" pitchFamily="34" charset="-120"/>
+              </a:rPr>
+              <a:t>For this project, two encoders are aligned to the extent that their representations agree on held-out sequences after the composition control: a measurement we report, not a goal we train toward.</a:t>
+            </a:r>
+            <a:endParaRPr lang="en-US" sz="1300" dirty="0"/>
+          </a:p>
+        </p:txBody>
+      </p:sp>
+    </p:spTree>
+  </p:cSld>
+  <p:clrMapOvr>
+    <a:masterClrMapping/>
+  </p:clrMapOvr>
+</p:sld>
+</file>
+
+<file path=ppt/slides/slide14.xml><?xml version="1.0" encoding="utf-8"?>
+<p:sld xmlns:a="http://schemas.openxmlformats.org/drawingml/2006/main" xmlns:r="http://schemas.openxmlformats.org/officeDocument/2006/relationships" xmlns:p="http://schemas.openxmlformats.org/presentationml/2006/main">
+  <p:cSld name="Slide 13">
+    <p:bg>
+      <p:bgPr>
+        <a:solidFill>
+          <a:srgbClr val="FAFBF8"/>
+        </a:solidFill>
+      </p:bgPr>
+    </p:bg>
+    <p:spTree>
+      <p:nvGrpSpPr>
+        <p:cNvPr id="1" name=""/>
+        <p:cNvGrpSpPr/>
+        <p:nvPr/>
+      </p:nvGrpSpPr>
+      <p:grpSpPr>
+        <a:xfrm>
+          <a:off x="0" y="0"/>
+          <a:ext cx="0" cy="0"/>
+          <a:chOff x="0" y="0"/>
+          <a:chExt cx="0" cy="0"/>
+        </a:xfrm>
+      </p:grpSpPr>
+      <p:sp>
+        <p:nvSpPr>
+          <p:cNvPr id="2" name="Eyebrow"/>
+          <p:cNvSpPr txBox="1"/>
+          <p:nvPr/>
+        </p:nvSpPr>
+        <p:spPr>
+          <a:xfrm>
+            <a:off x="685800" y="457200"/>
+            <a:ext cx="10817352" cy="320040"/>
+          </a:xfrm>
+          <a:prstGeom prst="rect">
+            <a:avLst/>
+          </a:prstGeom>
+          <a:noFill/>
+          <a:ln/>
+        </p:spPr>
+        <p:txBody>
+          <a:bodyPr wrap="square" lIns="0" tIns="0" rIns="0" bIns="0" rtlCol="0" anchor="ctr"/>
+          <a:lstStyle/>
+          <a:p>
+            <a:pPr indent="0" marL="0">
+              <a:buNone/>
+            </a:pPr>
+            <a:r>
+              <a:rPr lang="en-US" sz="1300" b="1" spc="300" kern="0" dirty="0">
+                <a:solidFill>
+                  <a:srgbClr val="3E7A34"/>
+                </a:solidFill>
+                <a:latin typeface="Calibri" pitchFamily="34" charset="0"/>
+                <a:ea typeface="Calibri" pitchFamily="34" charset="-122"/>
+                <a:cs typeface="Calibri" pitchFamily="34" charset="-120"/>
+              </a:rPr>
               <a:t>STAGE 2 · DECISION</a:t>
             </a:r>
             <a:endParaRPr lang="en-US" sz="1300" dirty="0"/>
@@ -10432,6 +11057,10 @@
             <a:prstDash val="solid"/>
           </a:ln>
         </p:spPr>
+        <p:txBody>
+          <a:bodyPr/>
+          <a:p/>
+        </p:txBody>
       </p:sp>
       <p:sp>
         <p:nvSpPr>
@@ -10537,6 +11166,10 @@
             <a:prstDash val="solid"/>
           </a:ln>
         </p:spPr>
+        <p:txBody>
+          <a:bodyPr/>
+          <a:p/>
+        </p:txBody>
       </p:sp>
       <p:sp>
         <p:nvSpPr>
@@ -10642,6 +11275,10 @@
             <a:prstDash val="solid"/>
           </a:ln>
         </p:spPr>
+        <p:txBody>
+          <a:bodyPr/>
+          <a:p/>
+        </p:txBody>
       </p:sp>
       <p:sp>
         <p:nvSpPr>
@@ -10747,6 +11384,10 @@
             <a:prstDash val="solid"/>
           </a:ln>
         </p:spPr>
+        <p:txBody>
+          <a:bodyPr/>
+          <a:p/>
+        </p:txBody>
       </p:sp>
       <p:sp>
         <p:nvSpPr>
@@ -10873,7 +11514,7 @@
 </p:sld>
 </file>
 
-<file path=ppt/slides/slide14.xml><?xml version="1.0" encoding="utf-8"?>
+<file path=ppt/slides/slide15.xml><?xml version="1.0" encoding="utf-8"?>
 <p:sld xmlns:a="http://schemas.openxmlformats.org/drawingml/2006/main" xmlns:r="http://schemas.openxmlformats.org/officeDocument/2006/relationships" xmlns:p="http://schemas.openxmlformats.org/presentationml/2006/main">
   <p:cSld name="Slide 14">
     <p:bg>
@@ -11174,7 +11815,7 @@
                 <a:ea typeface="Calibri" pitchFamily="34" charset="-122"/>
                 <a:cs typeface="Calibri" pitchFamily="34" charset="-120"/>
               </a:rPr>
-              <a:t>Secure GPU access and scale from the pilots to full training sets</a:t>
+              <a:t>Set up the GPU cluster and scale from the pilots to full training sets</a:t>
             </a:r>
             <a:endParaRPr lang="en-US" sz="1400" dirty="0"/>
           </a:p>
@@ -11206,6 +11847,10 @@
             <a:prstDash val="solid"/>
           </a:ln>
         </p:spPr>
+        <p:txBody>
+          <a:bodyPr/>
+          <a:p/>
+        </p:txBody>
       </p:sp>
       <p:sp>
         <p:nvSpPr>
@@ -11364,583 +12009,6 @@
 </p:sld>
 </file>
 
-<file path=ppt/slides/slide15.xml><?xml version="1.0" encoding="utf-8"?>
-<p:sld xmlns:a="http://schemas.openxmlformats.org/drawingml/2006/main" xmlns:r="http://schemas.openxmlformats.org/officeDocument/2006/relationships" xmlns:p="http://schemas.openxmlformats.org/presentationml/2006/main">
-  <p:cSld name="Slide 13">
-    <p:bg>
-      <p:bgPr>
-        <a:solidFill>
-          <a:srgbClr val="FAFBF8"/>
-        </a:solidFill>
-      </p:bgPr>
-    </p:bg>
-    <p:spTree>
-      <p:nvGrpSpPr>
-        <p:cNvPr id="1" name=""/>
-        <p:cNvGrpSpPr/>
-        <p:nvPr/>
-      </p:nvGrpSpPr>
-      <p:grpSpPr>
-        <a:xfrm>
-          <a:off x="0" y="0"/>
-          <a:ext cx="0" cy="0"/>
-          <a:chOff x="0" y="0"/>
-          <a:chExt cx="0" cy="0"/>
-        </a:xfrm>
-      </p:grpSpPr>
-      <p:sp>
-        <p:nvSpPr>
-          <p:cNvPr id="2" name="Eyebrow"/>
-          <p:cNvSpPr txBox="1"/>
-          <p:nvPr/>
-        </p:nvSpPr>
-        <p:spPr>
-          <a:xfrm>
-            <a:off x="685800" y="457200"/>
-            <a:ext cx="10817352" cy="320040"/>
-          </a:xfrm>
-          <a:prstGeom prst="rect">
-            <a:avLst/>
-          </a:prstGeom>
-          <a:noFill/>
-          <a:ln/>
-        </p:spPr>
-        <p:txBody>
-          <a:bodyPr wrap="square" lIns="0" tIns="0" rIns="0" bIns="0" rtlCol="0" anchor="ctr"/>
-          <a:lstStyle/>
-          <a:p>
-            <a:pPr indent="0" marL="0">
-              <a:buNone/>
-            </a:pPr>
-            <a:r>
-              <a:rPr lang="en-US" sz="1300" b="1" spc="300" kern="0" dirty="0">
-                <a:solidFill>
-                  <a:srgbClr val="3E7A34"/>
-                </a:solidFill>
-                <a:latin typeface="Calibri" pitchFamily="34" charset="0"/>
-                <a:ea typeface="Calibri" pitchFamily="34" charset="-122"/>
-                <a:cs typeface="Calibri" pitchFamily="34" charset="-120"/>
-              </a:rPr>
-              <a:t>STAGE 2 · WHAT ALIGNMENT MEANS</a:t>
-            </a:r>
-            <a:endParaRPr lang="en-US" sz="1300" dirty="0"/>
-          </a:p>
-        </p:txBody>
-      </p:sp>
-      <p:sp>
-        <p:nvSpPr>
-          <p:cNvPr id="3" name="Title"/>
-          <p:cNvSpPr txBox="1"/>
-          <p:nvPr/>
-        </p:nvSpPr>
-        <p:spPr>
-          <a:xfrm>
-            <a:off x="685800" y="777240"/>
-            <a:ext cx="10817352" cy="685800"/>
-          </a:xfrm>
-          <a:prstGeom prst="rect">
-            <a:avLst/>
-          </a:prstGeom>
-          <a:noFill/>
-          <a:ln/>
-        </p:spPr>
-        <p:txBody>
-          <a:bodyPr wrap="square" lIns="0" tIns="0" rIns="0" bIns="0" rtlCol="0" anchor="ctr"/>
-          <a:lstStyle/>
-          <a:p>
-            <a:pPr indent="0" marL="0">
-              <a:buNone/>
-            </a:pPr>
-            <a:r>
-              <a:rPr lang="en-US" sz="3200" b="1" dirty="0">
-                <a:solidFill>
-                  <a:srgbClr val="1E2A20"/>
-                </a:solidFill>
-                <a:latin typeface="Cambria" pitchFamily="34" charset="0"/>
-                <a:ea typeface="Cambria" pitchFamily="34" charset="-122"/>
-                <a:cs typeface="Cambria" pitchFamily="34" charset="-120"/>
-              </a:rPr>
-              <a:t>Two kinds of alignment: one given, one measured</a:t>
-            </a:r>
-            <a:endParaRPr lang="en-US" sz="3200" dirty="0"/>
-          </a:p>
-        </p:txBody>
-      </p:sp>
-      <p:sp>
-        <p:nvSpPr>
-          <p:cNvPr id="4" name="Card 1"/>
-          <p:cNvSpPr/>
-          <p:nvPr/>
-        </p:nvSpPr>
-        <p:spPr>
-          <a:xfrm>
-            <a:off x="685800" y="1645920"/>
-            <a:ext cx="5271516" cy="3566160"/>
-          </a:xfrm>
-          <a:prstGeom prst="roundRect">
-            <a:avLst>
-              <a:gd name="adj" fmla="val 3902"/>
-            </a:avLst>
-          </a:prstGeom>
-          <a:solidFill>
-            <a:srgbClr val="EEF3EA"/>
-          </a:solidFill>
-          <a:ln w="12700">
-            <a:solidFill>
-              <a:srgbClr val="EEF3EA"/>
-            </a:solidFill>
-            <a:prstDash val="solid"/>
-          </a:ln>
-        </p:spPr>
-      </p:sp>
-      <p:sp>
-        <p:nvSpPr>
-          <p:cNvPr id="5" name="Card 1 title"/>
-          <p:cNvSpPr txBox="1"/>
-          <p:nvPr/>
-        </p:nvSpPr>
-        <p:spPr>
-          <a:xfrm>
-            <a:off x="960120" y="1810512"/>
-            <a:ext cx="4722876" cy="365760"/>
-          </a:xfrm>
-          <a:prstGeom prst="rect">
-            <a:avLst/>
-          </a:prstGeom>
-          <a:noFill/>
-          <a:ln/>
-        </p:spPr>
-        <p:txBody>
-          <a:bodyPr wrap="square" lIns="0" tIns="0" rIns="0" bIns="0" rtlCol="0" anchor="ctr"/>
-          <a:lstStyle/>
-          <a:p>
-            <a:pPr indent="0" marL="0">
-              <a:buNone/>
-            </a:pPr>
-            <a:r>
-              <a:rPr lang="en-US" sz="1600" b="1" dirty="0">
-                <a:solidFill>
-                  <a:srgbClr val="1E2A20"/>
-                </a:solidFill>
-                <a:latin typeface="Calibri" pitchFamily="34" charset="0"/>
-                <a:ea typeface="Calibri" pitchFamily="34" charset="-122"/>
-                <a:cs typeface="Calibri" pitchFamily="34" charset="-120"/>
-              </a:rPr>
-              <a:t>Positional alignment: given by biology</a:t>
-            </a:r>
-            <a:endParaRPr lang="en-US" sz="1600" dirty="0"/>
-          </a:p>
-        </p:txBody>
-      </p:sp>
-      <p:sp>
-        <p:nvSpPr>
-          <p:cNvPr id="6" name="Card 1 body"/>
-          <p:cNvSpPr txBox="1"/>
-          <p:nvPr/>
-        </p:nvSpPr>
-        <p:spPr>
-          <a:xfrm>
-            <a:off x="960120" y="2249424"/>
-            <a:ext cx="4722876" cy="2798064"/>
-          </a:xfrm>
-          <a:prstGeom prst="rect">
-            <a:avLst/>
-          </a:prstGeom>
-          <a:noFill/>
-          <a:ln/>
-        </p:spPr>
-        <p:txBody>
-          <a:bodyPr wrap="square" lIns="0" tIns="0" rIns="0" bIns="0" rtlCol="0" anchor="t"/>
-          <a:lstStyle/>
-          <a:p>
-            <a:pPr indent="0" marL="0">
-              <a:spcAft>
-                <a:spcPts val="700"/>
-              </a:spcAft>
-              <a:buNone/>
-            </a:pPr>
-            <a:r>
-              <a:rPr lang="en-US" sz="1400" dirty="0">
-                <a:solidFill>
-                  <a:srgbClr val="46524A"/>
-                </a:solidFill>
-                <a:latin typeface="Calibri" pitchFamily="34" charset="0"/>
-                <a:ea typeface="Calibri" pitchFamily="34" charset="-122"/>
-                <a:cs typeface="Calibri" pitchFamily="34" charset="-120"/>
-              </a:rPr>
-              <a:t>Step t in every input must mean the same place in the gene, like video frame t and audio window t. Coupled Mamba needs this.</a:t>
-            </a:r>
-            <a:endParaRPr lang="en-US" sz="1400" dirty="0"/>
-          </a:p>
-          <a:p>
-            <a:pPr indent="0" marL="0">
-              <a:spcAft>
-                <a:spcPts val="300"/>
-              </a:spcAft>
-              <a:buNone/>
-            </a:pPr>
-            <a:r>
-              <a:rPr lang="en-US" sz="1400" b="1" dirty="0">
-                <a:solidFill>
-                  <a:srgbClr val="1E2A20"/>
-                </a:solidFill>
-                <a:latin typeface="Calibri" pitchFamily="34" charset="0"/>
-                <a:ea typeface="Calibri" pitchFamily="34" charset="-122"/>
-                <a:cs typeface="Calibri" pitchFamily="34" charset="-120"/>
-              </a:rPr>
-              <a:t>Stability: </a:t>
-            </a:r>
-            <a:r>
-              <a:rPr lang="en-US" sz="1400" dirty="0">
-                <a:solidFill>
-                  <a:srgbClr val="46524A"/>
-                </a:solidFill>
-                <a:latin typeface="Calibri" pitchFamily="34" charset="0"/>
-                <a:ea typeface="Calibri" pitchFamily="34" charset="-122"/>
-                <a:cs typeface="Calibri" pitchFamily="34" charset="-120"/>
-              </a:rPr>
-              <a:t>each codon maps to one amino acid, so every stream can be resampled to one codon grid. For a 900-nt coding sequence:</a:t>
-            </a:r>
-            <a:endParaRPr lang="en-US" sz="1400" dirty="0"/>
-          </a:p>
-          <a:p>
-            <a:pPr marL="285750" indent="-285750">
-              <a:spcAft>
-                <a:spcPts val="200"/>
-              </a:spcAft>
-              <a:buSzPct val="100000"/>
-              <a:buChar char="•"/>
-            </a:pPr>
-            <a:r>
-              <a:rPr lang="en-US" sz="1400" dirty="0">
-                <a:solidFill>
-                  <a:srgbClr val="46524A"/>
-                </a:solidFill>
-                <a:latin typeface="Calibri" pitchFamily="34" charset="0"/>
-                <a:ea typeface="Calibri" pitchFamily="34" charset="-122"/>
-                <a:cs typeface="Calibri" pitchFamily="34" charset="-120"/>
-              </a:rPr>
-              <a:t>RNA-FM: 900 nucleotide tokens, averaged in threes</a:t>
-            </a:r>
-            <a:endParaRPr lang="en-US" sz="1400" dirty="0"/>
-          </a:p>
-          <a:p>
-            <a:pPr marL="285750" indent="-285750">
-              <a:spcAft>
-                <a:spcPts val="200"/>
-              </a:spcAft>
-              <a:buSzPct val="100000"/>
-              <a:buChar char="•"/>
-            </a:pPr>
-            <a:r>
-              <a:rPr lang="en-US" sz="1400" dirty="0">
-                <a:solidFill>
-                  <a:srgbClr val="46524A"/>
-                </a:solidFill>
-                <a:latin typeface="Calibri" pitchFamily="34" charset="0"/>
-                <a:ea typeface="Calibri" pitchFamily="34" charset="-122"/>
-                <a:cs typeface="Calibri" pitchFamily="34" charset="-120"/>
-              </a:rPr>
-              <a:t>NT 500M: 150 six-nucleotide tokens, each split in two</a:t>
-            </a:r>
-            <a:endParaRPr lang="en-US" sz="1400" dirty="0"/>
-          </a:p>
-          <a:p>
-            <a:pPr marL="285750" indent="-285750">
-              <a:spcAft>
-                <a:spcPts val="700"/>
-              </a:spcAft>
-              <a:buSzPct val="100000"/>
-              <a:buChar char="•"/>
-            </a:pPr>
-            <a:r>
-              <a:rPr lang="en-US" sz="1400" dirty="0">
-                <a:solidFill>
-                  <a:srgbClr val="46524A"/>
-                </a:solidFill>
-                <a:latin typeface="Calibri" pitchFamily="34" charset="0"/>
-                <a:ea typeface="Calibri" pitchFamily="34" charset="-122"/>
-                <a:cs typeface="Calibri" pitchFamily="34" charset="-120"/>
-              </a:rPr>
-              <a:t>CaLM (300 codons), ESM-2 (about 300 amino acids): already one per codon</a:t>
-            </a:r>
-            <a:endParaRPr lang="en-US" sz="1400" dirty="0"/>
-          </a:p>
-          <a:p>
-            <a:pPr indent="0" marL="0">
-              <a:buNone/>
-            </a:pPr>
-            <a:r>
-              <a:rPr lang="en-US" sz="1400" b="1" dirty="0">
-                <a:solidFill>
-                  <a:srgbClr val="1E2A20"/>
-                </a:solidFill>
-                <a:latin typeface="Calibri" pitchFamily="34" charset="0"/>
-                <a:ea typeface="Calibri" pitchFamily="34" charset="-122"/>
-                <a:cs typeface="Calibri" pitchFamily="34" charset="-120"/>
-              </a:rPr>
-              <a:t>GTEx: </a:t>
-            </a:r>
-            <a:r>
-              <a:rPr lang="en-US" sz="1400" dirty="0">
-                <a:solidFill>
-                  <a:srgbClr val="46524A"/>
-                </a:solidFill>
-                <a:latin typeface="Calibri" pitchFamily="34" charset="0"/>
-                <a:ea typeface="Calibri" pitchFamily="34" charset="-122"/>
-                <a:cs typeface="Calibri" pitchFamily="34" charset="-120"/>
-              </a:rPr>
-              <a:t>promoter DNA, transcript, and protein have no position-by-position match, so fusion uses cross-attention.</a:t>
-            </a:r>
-            <a:endParaRPr lang="en-US" sz="1400" dirty="0"/>
-          </a:p>
-        </p:txBody>
-      </p:sp>
-      <p:sp>
-        <p:nvSpPr>
-          <p:cNvPr id="7" name="Card 2"/>
-          <p:cNvSpPr/>
-          <p:nvPr/>
-        </p:nvSpPr>
-        <p:spPr>
-          <a:xfrm>
-            <a:off x="6231636" y="1645920"/>
-            <a:ext cx="5271516" cy="3566160"/>
-          </a:xfrm>
-          <a:prstGeom prst="roundRect">
-            <a:avLst>
-              <a:gd name="adj" fmla="val 3902"/>
-            </a:avLst>
-          </a:prstGeom>
-          <a:solidFill>
-            <a:srgbClr val="EEF3EA"/>
-          </a:solidFill>
-          <a:ln w="12700">
-            <a:solidFill>
-              <a:srgbClr val="EEF3EA"/>
-            </a:solidFill>
-            <a:prstDash val="solid"/>
-          </a:ln>
-        </p:spPr>
-      </p:sp>
-      <p:sp>
-        <p:nvSpPr>
-          <p:cNvPr id="8" name="Card 2 title"/>
-          <p:cNvSpPr txBox="1"/>
-          <p:nvPr/>
-        </p:nvSpPr>
-        <p:spPr>
-          <a:xfrm>
-            <a:off x="6505956" y="1810512"/>
-            <a:ext cx="4722876" cy="365760"/>
-          </a:xfrm>
-          <a:prstGeom prst="rect">
-            <a:avLst/>
-          </a:prstGeom>
-          <a:noFill/>
-          <a:ln/>
-        </p:spPr>
-        <p:txBody>
-          <a:bodyPr wrap="square" lIns="0" tIns="0" rIns="0" bIns="0" rtlCol="0" anchor="ctr"/>
-          <a:lstStyle/>
-          <a:p>
-            <a:pPr indent="0" marL="0">
-              <a:buNone/>
-            </a:pPr>
-            <a:r>
-              <a:rPr lang="en-US" sz="1600" b="1" dirty="0">
-                <a:solidFill>
-                  <a:srgbClr val="1E2A20"/>
-                </a:solidFill>
-                <a:latin typeface="Calibri" pitchFamily="34" charset="0"/>
-                <a:ea typeface="Calibri" pitchFamily="34" charset="-122"/>
-                <a:cs typeface="Calibri" pitchFamily="34" charset="-120"/>
-              </a:rPr>
-              <a:t>Representational alignment: measured</a:t>
-            </a:r>
-            <a:endParaRPr lang="en-US" sz="1600" dirty="0"/>
-          </a:p>
-        </p:txBody>
-      </p:sp>
-      <p:sp>
-        <p:nvSpPr>
-          <p:cNvPr id="9" name="Card 2 body"/>
-          <p:cNvSpPr txBox="1"/>
-          <p:nvPr/>
-        </p:nvSpPr>
-        <p:spPr>
-          <a:xfrm>
-            <a:off x="6505956" y="2249424"/>
-            <a:ext cx="4722876" cy="2798064"/>
-          </a:xfrm>
-          <a:prstGeom prst="rect">
-            <a:avLst/>
-          </a:prstGeom>
-          <a:noFill/>
-          <a:ln/>
-        </p:spPr>
-        <p:txBody>
-          <a:bodyPr wrap="square" lIns="0" tIns="0" rIns="0" bIns="0" rtlCol="0" anchor="t"/>
-          <a:lstStyle/>
-          <a:p>
-            <a:pPr indent="0" marL="0">
-              <a:spcAft>
-                <a:spcPts val="700"/>
-              </a:spcAft>
-              <a:buNone/>
-            </a:pPr>
-            <a:r>
-              <a:rPr lang="en-US" sz="1400" dirty="0">
-                <a:solidFill>
-                  <a:srgbClr val="46524A"/>
-                </a:solidFill>
-                <a:latin typeface="Calibri" pitchFamily="34" charset="0"/>
-                <a:ea typeface="Calibri" pitchFamily="34" charset="-122"/>
-                <a:cs typeface="Calibri" pitchFamily="34" charset="-120"/>
-              </a:rPr>
-              <a:t>Do two encoders see the same genes as similar? Stage 1 measured it with CKA, nearest neighbors, RSA, and CCA retrieval.</a:t>
-            </a:r>
-            <a:endParaRPr lang="en-US" sz="1400" dirty="0"/>
-          </a:p>
-          <a:p>
-            <a:pPr indent="0" marL="0">
-              <a:spcAft>
-                <a:spcPts val="700"/>
-              </a:spcAft>
-              <a:buNone/>
-            </a:pPr>
-            <a:r>
-              <a:rPr lang="en-US" sz="1400" b="1" dirty="0">
-                <a:solidFill>
-                  <a:srgbClr val="1E2A20"/>
-                </a:solidFill>
-                <a:latin typeface="Calibri" pitchFamily="34" charset="0"/>
-                <a:ea typeface="Calibri" pitchFamily="34" charset="-122"/>
-                <a:cs typeface="Calibri" pitchFamily="34" charset="-120"/>
-              </a:rPr>
-              <a:t>Mostly composition. </a:t>
-            </a:r>
-            <a:r>
-              <a:rPr lang="en-US" sz="1400" dirty="0">
-                <a:solidFill>
-                  <a:srgbClr val="46524A"/>
-                </a:solidFill>
-                <a:latin typeface="Calibri" pitchFamily="34" charset="0"/>
-                <a:ea typeface="Calibri" pitchFamily="34" charset="-122"/>
-                <a:cs typeface="Calibri" pitchFamily="34" charset="-120"/>
-              </a:rPr>
-              <a:t>Removing letter, codon, and amino-acid counts cuts CKA 52% to 90% for every pair with a DNA encoder.</a:t>
-            </a:r>
-            <a:endParaRPr lang="en-US" sz="1400" dirty="0"/>
-          </a:p>
-          <a:p>
-            <a:pPr indent="0" marL="0">
-              <a:spcAft>
-                <a:spcPts val="700"/>
-              </a:spcAft>
-              <a:buNone/>
-            </a:pPr>
-            <a:r>
-              <a:rPr lang="en-US" sz="1400" b="1" dirty="0">
-                <a:solidFill>
-                  <a:srgbClr val="1E2A20"/>
-                </a:solidFill>
-                <a:latin typeface="Calibri" pitchFamily="34" charset="0"/>
-                <a:ea typeface="Calibri" pitchFamily="34" charset="-122"/>
-                <a:cs typeface="Calibri" pitchFamily="34" charset="-120"/>
-              </a:rPr>
-              <a:t>Few pairs survive. </a:t>
-            </a:r>
-            <a:r>
-              <a:rPr lang="en-US" sz="1400" dirty="0">
-                <a:solidFill>
-                  <a:srgbClr val="46524A"/>
-                </a:solidFill>
-                <a:latin typeface="Calibri" pitchFamily="34" charset="0"/>
-                <a:ea typeface="Calibri" pitchFamily="34" charset="-122"/>
-                <a:cs typeface="Calibri" pitchFamily="34" charset="-120"/>
-              </a:rPr>
-              <a:t>ESM-2 models, RNA-FM with RiNALMo, and CaLM with protein, which still finds its protein partner 58% to 69% of the time (chance 0.3%).</a:t>
-            </a:r>
-            <a:endParaRPr lang="en-US" sz="1400" dirty="0"/>
-          </a:p>
-          <a:p>
-            <a:pPr indent="0" marL="0">
-              <a:buNone/>
-            </a:pPr>
-            <a:r>
-              <a:rPr lang="en-US" sz="1400" b="1" dirty="0">
-                <a:solidFill>
-                  <a:srgbClr val="1E2A20"/>
-                </a:solidFill>
-                <a:latin typeface="Calibri" pitchFamily="34" charset="0"/>
-                <a:ea typeface="Calibri" pitchFamily="34" charset="-122"/>
-                <a:cs typeface="Calibri" pitchFamily="34" charset="-120"/>
-              </a:rPr>
-              <a:t>Not usefulness. </a:t>
-            </a:r>
-            <a:r>
-              <a:rPr lang="en-US" sz="1400" dirty="0">
-                <a:solidFill>
-                  <a:srgbClr val="46524A"/>
-                </a:solidFill>
-                <a:latin typeface="Calibri" pitchFamily="34" charset="0"/>
-                <a:ea typeface="Calibri" pitchFamily="34" charset="-122"/>
-                <a:cs typeface="Calibri" pitchFamily="34" charset="-120"/>
-              </a:rPr>
-              <a:t>Alignment never tracks prediction error (66 pairs, both datasets), and some of the best pairings barely align.</a:t>
-            </a:r>
-            <a:endParaRPr lang="en-US" sz="1400" dirty="0"/>
-          </a:p>
-        </p:txBody>
-      </p:sp>
-      <p:sp>
-        <p:nvSpPr>
-          <p:cNvPr id="10" name="Definition"/>
-          <p:cNvSpPr txBox="1"/>
-          <p:nvPr/>
-        </p:nvSpPr>
-        <p:spPr>
-          <a:xfrm>
-            <a:off x="685800" y="5394960"/>
-            <a:ext cx="10817352" cy="457200"/>
-          </a:xfrm>
-          <a:prstGeom prst="rect">
-            <a:avLst/>
-          </a:prstGeom>
-          <a:noFill/>
-          <a:ln/>
-        </p:spPr>
-        <p:txBody>
-          <a:bodyPr wrap="square" lIns="0" tIns="0" rIns="0" bIns="0" rtlCol="0" anchor="ctr"/>
-          <a:lstStyle/>
-          <a:p>
-            <a:pPr indent="0" marL="0">
-              <a:buNone/>
-            </a:pPr>
-            <a:r>
-              <a:rPr lang="en-US" sz="1300" i="1" dirty="0">
-                <a:solidFill>
-                  <a:srgbClr val="46524A"/>
-                </a:solidFill>
-                <a:latin typeface="Calibri" pitchFamily="34" charset="0"/>
-                <a:ea typeface="Calibri" pitchFamily="34" charset="-122"/>
-                <a:cs typeface="Calibri" pitchFamily="34" charset="-120"/>
-              </a:rPr>
-              <a:t>For this project, two encoders are aligned to the extent that their representations agree on held-out sequences after the composition control: a measurement we report, not a goal we train toward.</a:t>
-            </a:r>
-            <a:endParaRPr lang="en-US" sz="1300" dirty="0"/>
-          </a:p>
-        </p:txBody>
-      </p:sp>
-    </p:spTree>
-  </p:cSld>
-  <p:clrMapOvr>
-    <a:masterClrMapping/>
-  </p:clrMapOvr>
-</p:sld>
-</file>
-
 <file path=ppt/slides/slide2.xml><?xml version="1.0" encoding="utf-8"?>
 <p:sld xmlns:a="http://schemas.openxmlformats.org/drawingml/2006/main" xmlns:r="http://schemas.openxmlformats.org/officeDocument/2006/relationships" xmlns:p="http://schemas.openxmlformats.org/presentationml/2006/main">
   <p:cSld name="Slide 2">
@@ -12076,7 +12144,7 @@
                 <a:ea typeface="Calibri" pitchFamily="34" charset="-122"/>
                 <a:cs typeface="Calibri" pitchFamily="34" charset="-120"/>
               </a:rPr>
-              <a:t>All encoders frozen; mean-pooled final layer; ridge probes over gene- or sequence-grouped folds. One notebook: Code/Stage1_analysis.ipynb.</a:t>
+              <a:t>All encoders frozen; mean-pooled final layer; ridge probes over gene- or sequence-grouped folds. Two notebooks: Code/Stage1_stability.ipynb and Code/Stage1_gtex.ipynb.</a:t>
             </a:r>
             <a:endParaRPr lang="en-US" sz="1100" dirty="0"/>
           </a:p>
@@ -12108,6 +12176,10 @@
             <a:prstDash val="solid"/>
           </a:ln>
         </p:spPr>
+        <p:txBody>
+          <a:bodyPr/>
+          <a:p/>
+        </p:txBody>
       </p:sp>
       <p:sp>
         <p:nvSpPr>
@@ -12252,6 +12324,10 @@
             <a:prstDash val="solid"/>
           </a:ln>
         </p:spPr>
+        <p:txBody>
+          <a:bodyPr/>
+          <a:p/>
+        </p:txBody>
       </p:sp>
       <p:sp>
         <p:nvSpPr>
@@ -12396,6 +12472,10 @@
             <a:prstDash val="solid"/>
           </a:ln>
         </p:spPr>
+        <p:txBody>
+          <a:bodyPr/>
+          <a:p/>
+        </p:txBody>
       </p:sp>
       <p:sp>
         <p:nvSpPr>
@@ -12540,6 +12620,10 @@
             <a:prstDash val="solid"/>
           </a:ln>
         </p:spPr>
+        <p:txBody>
+          <a:bodyPr/>
+          <a:p/>
+        </p:txBody>
       </p:sp>
       <p:sp>
         <p:nvSpPr>
@@ -12684,6 +12768,10 @@
             <a:prstDash val="solid"/>
           </a:ln>
         </p:spPr>
+        <p:txBody>
+          <a:bodyPr/>
+          <a:p/>
+        </p:txBody>
       </p:sp>
       <p:sp>
         <p:nvSpPr>
@@ -17581,6 +17669,10 @@
             <a:prstDash val="solid"/>
           </a:ln>
         </p:spPr>
+        <p:txBody>
+          <a:bodyPr/>
+          <a:p/>
+        </p:txBody>
       </p:sp>
       <p:sp>
         <p:nvSpPr>
@@ -17686,6 +17778,10 @@
             <a:prstDash val="solid"/>
           </a:ln>
         </p:spPr>
+        <p:txBody>
+          <a:bodyPr/>
+          <a:p/>
+        </p:txBody>
       </p:sp>
       <p:sp>
         <p:nvSpPr>
@@ -21423,6 +21519,10 @@
             <a:prstDash val="solid"/>
           </a:ln>
         </p:spPr>
+        <p:txBody>
+          <a:bodyPr/>
+          <a:p/>
+        </p:txBody>
       </p:sp>
       <p:sp>
         <p:nvSpPr>
@@ -21528,6 +21628,10 @@
             <a:prstDash val="solid"/>
           </a:ln>
         </p:spPr>
+        <p:txBody>
+          <a:bodyPr/>
+          <a:p/>
+        </p:txBody>
       </p:sp>
       <p:sp>
         <p:nvSpPr>
@@ -33040,6 +33144,10 @@
             <a:prstDash val="solid"/>
           </a:ln>
         </p:spPr>
+        <p:txBody>
+          <a:bodyPr/>
+          <a:p/>
+        </p:txBody>
       </p:sp>
       <p:sp>
         <p:nvSpPr>
@@ -33145,6 +33253,10 @@
             <a:prstDash val="solid"/>
           </a:ln>
         </p:spPr>
+        <p:txBody>
+          <a:bodyPr/>
+          <a:p/>
+        </p:txBody>
       </p:sp>
       <p:sp>
         <p:nvSpPr>
@@ -35433,6 +35545,10 @@
             <a:prstDash val="solid"/>
           </a:ln>
         </p:spPr>
+        <p:txBody>
+          <a:bodyPr/>
+          <a:p/>
+        </p:txBody>
       </p:sp>
       <p:sp>
         <p:nvSpPr>
@@ -39137,6 +39253,10 @@
             <a:prstDash val="solid"/>
           </a:ln>
         </p:spPr>
+        <p:txBody>
+          <a:bodyPr/>
+          <a:p/>
+        </p:txBody>
       </p:sp>
       <p:sp>
         <p:nvSpPr>
@@ -39242,6 +39362,10 @@
             <a:prstDash val="solid"/>
           </a:ln>
         </p:spPr>
+        <p:txBody>
+          <a:bodyPr/>
+          <a:p/>
+        </p:txBody>
       </p:sp>
       <p:sp>
         <p:nvSpPr>

</xml_diff>